<commit_message>
Add rescinded contracts & recovery failure chapter — named cases
New Chapter 8B (IFMS article) + Ch.6C (eMB article):
- ~200 contracts rescinded statewide — ZERO systematic recovery monitoring
- Named Case 1: Bhairavji Bridge, Banswara — rescinded, nil recovery
- Named Case 2: Kotada Road, Udaipur — rescinded, nil recovery
- Named Case 3: Gannon Dunkerlay & Co — established firm, contract
  rescinded, substantial dues unrecovered, company walked free
- Broken incentive structure analysis: rescission = paper threat
- 4 mandatory reforms: centralised recovery register, legal priority,
  mandatory blacklisting, named-case CAG+ACB scrutiny
- New media demands: Recovery RTI + blacklist public register
- All 6 DOCX/PDF/PPTX exports regenerated with new chapter
- News.txt updated with full investigation text
</commit_message>
<xml_diff>
--- a/artifacts/rajasthan-ifms-crisis/IFMS-Rajasthan-Investigation.pptx
+++ b/artifacts/rajasthan-ifms-crisis/IFMS-Rajasthan-Investigation.pptx
@@ -21,6 +21,7 @@
     <p:sldId id="269" r:id="rId20"/>
     <p:sldId id="270" r:id="rId21"/>
     <p:sldId id="271" r:id="rId22"/>
+    <p:sldId id="272" r:id="rId23"/>
   </p:sldIdLst>
   <p:sldSz cx="12188952" cy="6858000" type="screen4x3"/>
   <p:notesSz cx="6858000" cy="9144000"/>
@@ -3968,7 +3969,7 @@
                   <a:srgbClr val="64788C"/>
                 </a:solidFill>
               </a:rPr>
-              <a:t>10 / 15</a:t>
+              <a:t>10 / 16</a:t>
             </a:r>
           </a:p>
         </p:txBody>
@@ -4418,7 +4419,7 @@
                   <a:srgbClr val="64788C"/>
                 </a:solidFill>
               </a:rPr>
-              <a:t>11 / 15</a:t>
+              <a:t>11 / 16</a:t>
             </a:r>
           </a:p>
         </p:txBody>
@@ -4868,7 +4869,7 @@
                   <a:srgbClr val="64788C"/>
                 </a:solidFill>
               </a:rPr>
-              <a:t>12 / 15</a:t>
+              <a:t>12 / 16</a:t>
             </a:r>
           </a:p>
         </p:txBody>
@@ -5318,7 +5319,7 @@
                   <a:srgbClr val="64788C"/>
                 </a:solidFill>
               </a:rPr>
-              <a:t>13 / 15</a:t>
+              <a:t>13 / 16</a:t>
             </a:r>
           </a:p>
         </p:txBody>
@@ -5507,7 +5508,7 @@
                   <a:srgbClr val="FFFFFF"/>
                 </a:solidFill>
               </a:rPr>
-              <a:t>Ch.9</a:t>
+              <a:t>Ch.8B</a:t>
             </a:r>
           </a:p>
         </p:txBody>
@@ -5541,7 +5542,7 @@
                   <a:srgbClr val="FFFFFF"/>
                 </a:solidFill>
               </a:rPr>
-              <a:t>सात तत्काल माँगें</a:t>
+              <a:t>~200 रद्द अनुबंध — वसूली शून्य: नामित ठेकेदार बेखौफ</a:t>
             </a:r>
           </a:p>
         </p:txBody>
@@ -5575,7 +5576,7 @@
                   <a:srgbClr val="A0C8DC"/>
                 </a:solidFill>
               </a:rPr>
-              <a:t>Seven Immediate Demands</a:t>
+              <a:t>~200 Rescinded Contracts — Zero Recovery: Named Defaulters Walk Free</a:t>
             </a:r>
           </a:p>
         </p:txBody>
@@ -5652,10 +5653,12 @@
                   <a:srgbClr val="DCE1E6"/>
                 </a:solidFill>
               </a:rPr>
-              <a:t>1. Statutory Delegation Order (Gazette Notification)। 2. नागरिक पारदर्शिता। 3.
-DSC अधिकारी के पास — operator के नहीं। 4. अनिवार्य Training। 5. Portal bugs
-deadline के साथ fix हों। 6. 24×7 Dedicated Helpline। 7. Independent Monitoring
-Committee।</a:t>
+              <a:t>~200 contracts rescinded — Risk and Cost tenders floated — लेकिन recovery
+monitor नहीं होती। तीन नामित मामले: (1) भैरवजी Bridge, बाँसवाड़ा — rescinded,
+वसूली शून्य। (2) Kotada Road, उदयपुर — rescinded, differential cost unrecovered।
+(3) Gannon Dunkerlay — established company, contract rescinded, department
+entitlement unexercised, company walked free। Rescission एक कागज़ी खतरा बन गया —
+असली financial liability नहीं। ठेकेदार के लिए contract तोड़ने का कोई दाम नहीं।</a:t>
             </a:r>
           </a:p>
         </p:txBody>
@@ -5689,10 +5692,16 @@
                   <a:srgbClr val="AAB9C3"/>
                 </a:solidFill>
               </a:rPr>
-              <a:t>1. Statutory Delegation Order (Gazette Notification). 2. Citizen Transparency.
-3. DSC must stay with officer — not at computer centre. 4. Mandatory
-comprehensive training. 5. Portal bugs fixed with deadline. 6. 24x7 dedicated
-helpline. 7. Independent Monitoring Committee.</a:t>
+              <a:t>Approximately 200 contracts have been rescinded for incomplete execution in
+Rajasthan PWD. Risk-and-cost tenders were invited. But there is no regular
+monitoring of recovery against defaulters. Three named examples: (1) Bhairavji
+Bridge, Banswara — rescinded, risk-and-cost tender floated, zero recovery from
+contractor. (2) Kotada Road, Udaipur — rescinded, differential cost unrecovered.
+(3) Gannon Dunkerlay &amp; Company — established firm, contract rescinded,
+substantial department entitlement unexercised, company walked free. Pattern:
+rescission is a paper threat, not a real financial liability. Mandatory reforms:
+centralised risk-and-cost recovery register in IFMS, mandatory blacklisting
+until full recovery, named-case CAG audit and ACB investigation.</a:t>
             </a:r>
           </a:p>
         </p:txBody>
@@ -5769,7 +5778,7 @@
                   <a:srgbClr val="64788C"/>
                 </a:solidFill>
               </a:rPr>
-              <a:t>14 / 15</a:t>
+              <a:t>14 / 16</a:t>
             </a:r>
           </a:p>
         </p:txBody>
@@ -5958,7 +5967,7 @@
                   <a:srgbClr val="FFFFFF"/>
                 </a:solidFill>
               </a:rPr>
-              <a:t>Ch.10</a:t>
+              <a:t>Ch.9</a:t>
             </a:r>
           </a:p>
         </p:txBody>
@@ -5992,7 +6001,7 @@
                   <a:srgbClr val="FFFFFF"/>
                 </a:solidFill>
               </a:rPr>
-              <a:t>चौथे स्तंभ से आह्वान — 10 मीडिया माँगें</a:t>
+              <a:t>सात तत्काल माँगें</a:t>
             </a:r>
           </a:p>
         </p:txBody>
@@ -6026,7 +6035,7 @@
                   <a:srgbClr val="A0C8DC"/>
                 </a:solidFill>
               </a:rPr>
-              <a:t>Call to the Fourth Estate — 10 Media Demands</a:t>
+              <a:t>Seven Immediate Demands</a:t>
             </a:r>
           </a:p>
         </p:txBody>
@@ -6103,9 +6112,10 @@
                   <a:srgbClr val="DCE1E6"/>
                 </a:solidFill>
               </a:rPr>
-              <a:t>1.Delegation RTI 2.AS/FS Backdating CAG Audit 3.IP Login Audit→ACB 4.XEN Login
-Sting 5.DSC Location Check 6.Live Helpline Test 7.Morphed Photo Expose 8.Public
-Audit माँग 9.One Operator Three Roles Expose 10.Public Monitoring अनिवार्य।</a:t>
+              <a:t>1. Statutory Delegation Order (Gazette Notification)। 2. नागरिक पारदर्शिता। 3.
+DSC अधिकारी के पास — operator के नहीं। 4. अनिवार्य Training। 5. Portal bugs
+deadline के साथ fix हों। 6. 24×7 Dedicated Helpline। 7. Independent Monitoring
+Committee।</a:t>
             </a:r>
           </a:p>
         </p:txBody>
@@ -6139,10 +6149,10 @@
                   <a:srgbClr val="AAB9C3"/>
                 </a:solidFill>
               </a:rPr>
-              <a:t>1.RTI on delegation circular 2.AS/FS backdating CAG audit 3.IP Login Audit→ACB
-4.XEN Login sting 5.DSC location check 6.Live helpline call test 7.Morphed photo
-expose 8.Public audit demand 9.One operator three roles expose 10.Public
-monitoring mandate.</a:t>
+              <a:t>1. Statutory Delegation Order (Gazette Notification). 2. Citizen Transparency.
+3. DSC must stay with officer — not at computer centre. 4. Mandatory
+comprehensive training. 5. Portal bugs fixed with deadline. 6. 24x7 dedicated
+helpline. 7. Independent Monitoring Committee.</a:t>
             </a:r>
           </a:p>
         </p:txBody>
@@ -6219,7 +6229,7 @@
                   <a:srgbClr val="64788C"/>
                 </a:solidFill>
               </a:rPr>
-              <a:t>15 / 15</a:t>
+              <a:t>15 / 16</a:t>
             </a:r>
           </a:p>
         </p:txBody>
@@ -6233,6 +6243,456 @@
 </file>
 
 <file path=ppt/slides/slide16.xml><?xml version="1.0" encoding="utf-8"?>
+<p:sld xmlns:a="http://schemas.openxmlformats.org/drawingml/2006/main" xmlns:p="http://schemas.openxmlformats.org/presentationml/2006/main" xmlns:r="http://schemas.openxmlformats.org/officeDocument/2006/relationships">
+  <p:cSld>
+    <p:bg>
+      <p:bgPr>
+        <a:solidFill>
+          <a:srgbClr val="0F2A3E"/>
+        </a:solidFill>
+        <a:effectLst/>
+      </p:bgPr>
+    </p:bg>
+    <p:spTree>
+      <p:nvGrpSpPr>
+        <p:cNvPr id="1" name=""/>
+        <p:cNvGrpSpPr/>
+        <p:nvPr/>
+      </p:nvGrpSpPr>
+      <p:grpSpPr/>
+      <p:sp>
+        <p:nvSpPr>
+          <p:cNvPr id="2" name="Rectangle 1"/>
+          <p:cNvSpPr/>
+          <p:nvPr/>
+        </p:nvSpPr>
+        <p:spPr>
+          <a:xfrm>
+            <a:off x="0" y="0"/>
+            <a:ext cx="12188952" cy="64008"/>
+          </a:xfrm>
+          <a:prstGeom prst="rect">
+            <a:avLst/>
+          </a:prstGeom>
+          <a:solidFill>
+            <a:srgbClr val="0D9488"/>
+          </a:solidFill>
+          <a:ln>
+            <a:noFill/>
+          </a:ln>
+        </p:spPr>
+        <p:style>
+          <a:lnRef idx="1">
+            <a:schemeClr val="accent1"/>
+          </a:lnRef>
+          <a:fillRef idx="3">
+            <a:schemeClr val="accent1"/>
+          </a:fillRef>
+          <a:effectRef idx="2">
+            <a:schemeClr val="accent1"/>
+          </a:effectRef>
+          <a:fontRef idx="minor">
+            <a:schemeClr val="lt1"/>
+          </a:fontRef>
+        </p:style>
+        <p:txBody>
+          <a:bodyPr rtlCol="0" anchor="ctr"/>
+          <a:lstStyle/>
+          <a:p>
+            <a:pPr algn="ctr"/>
+          </a:p>
+        </p:txBody>
+      </p:sp>
+      <p:sp>
+        <p:nvSpPr>
+          <p:cNvPr id="3" name="Rectangle 2"/>
+          <p:cNvSpPr/>
+          <p:nvPr/>
+        </p:nvSpPr>
+        <p:spPr>
+          <a:xfrm>
+            <a:off x="0" y="6793992"/>
+            <a:ext cx="12188952" cy="64008"/>
+          </a:xfrm>
+          <a:prstGeom prst="rect">
+            <a:avLst/>
+          </a:prstGeom>
+          <a:solidFill>
+            <a:srgbClr val="0D9488"/>
+          </a:solidFill>
+          <a:ln>
+            <a:noFill/>
+          </a:ln>
+        </p:spPr>
+        <p:style>
+          <a:lnRef idx="1">
+            <a:schemeClr val="accent1"/>
+          </a:lnRef>
+          <a:fillRef idx="3">
+            <a:schemeClr val="accent1"/>
+          </a:fillRef>
+          <a:effectRef idx="2">
+            <a:schemeClr val="accent1"/>
+          </a:effectRef>
+          <a:fontRef idx="minor">
+            <a:schemeClr val="lt1"/>
+          </a:fontRef>
+        </p:style>
+        <p:txBody>
+          <a:bodyPr rtlCol="0" anchor="ctr"/>
+          <a:lstStyle/>
+          <a:p>
+            <a:pPr algn="ctr"/>
+          </a:p>
+        </p:txBody>
+      </p:sp>
+      <p:sp>
+        <p:nvSpPr>
+          <p:cNvPr id="4" name="Rectangle 3"/>
+          <p:cNvSpPr/>
+          <p:nvPr/>
+        </p:nvSpPr>
+        <p:spPr>
+          <a:xfrm>
+            <a:off x="274320" y="164592"/>
+            <a:ext cx="1005840" cy="411480"/>
+          </a:xfrm>
+          <a:prstGeom prst="rect">
+            <a:avLst/>
+          </a:prstGeom>
+          <a:solidFill>
+            <a:srgbClr val="0D9488"/>
+          </a:solidFill>
+          <a:ln>
+            <a:noFill/>
+          </a:ln>
+        </p:spPr>
+        <p:style>
+          <a:lnRef idx="1">
+            <a:schemeClr val="accent1"/>
+          </a:lnRef>
+          <a:fillRef idx="3">
+            <a:schemeClr val="accent1"/>
+          </a:fillRef>
+          <a:effectRef idx="2">
+            <a:schemeClr val="accent1"/>
+          </a:effectRef>
+          <a:fontRef idx="minor">
+            <a:schemeClr val="lt1"/>
+          </a:fontRef>
+        </p:style>
+        <p:txBody>
+          <a:bodyPr rtlCol="0" anchor="ctr"/>
+          <a:lstStyle/>
+          <a:p>
+            <a:pPr algn="ctr"/>
+          </a:p>
+        </p:txBody>
+      </p:sp>
+      <p:sp>
+        <p:nvSpPr>
+          <p:cNvPr id="5" name="TextBox 4"/>
+          <p:cNvSpPr txBox="1"/>
+          <p:nvPr/>
+        </p:nvSpPr>
+        <p:spPr>
+          <a:xfrm>
+            <a:off x="274320" y="164592"/>
+            <a:ext cx="1005840" cy="411480"/>
+          </a:xfrm>
+          <a:prstGeom prst="rect">
+            <a:avLst/>
+          </a:prstGeom>
+          <a:noFill/>
+        </p:spPr>
+        <p:txBody>
+          <a:bodyPr wrap="square">
+            <a:spAutoFit/>
+          </a:bodyPr>
+          <a:lstStyle/>
+          <a:p>
+            <a:pPr algn="ctr"/>
+            <a:r>
+              <a:rPr sz="1100" b="1" i="0">
+                <a:solidFill>
+                  <a:srgbClr val="FFFFFF"/>
+                </a:solidFill>
+              </a:rPr>
+              <a:t>Ch.10</a:t>
+            </a:r>
+          </a:p>
+        </p:txBody>
+      </p:sp>
+      <p:sp>
+        <p:nvSpPr>
+          <p:cNvPr id="6" name="TextBox 5"/>
+          <p:cNvSpPr txBox="1"/>
+          <p:nvPr/>
+        </p:nvSpPr>
+        <p:spPr>
+          <a:xfrm>
+            <a:off x="1417320" y="137160"/>
+            <a:ext cx="10424160" cy="548640"/>
+          </a:xfrm>
+          <a:prstGeom prst="rect">
+            <a:avLst/>
+          </a:prstGeom>
+          <a:noFill/>
+        </p:spPr>
+        <p:txBody>
+          <a:bodyPr wrap="square">
+            <a:spAutoFit/>
+          </a:bodyPr>
+          <a:lstStyle/>
+          <a:p>
+            <a:pPr algn="l"/>
+            <a:r>
+              <a:rPr sz="1800" b="1" i="0">
+                <a:solidFill>
+                  <a:srgbClr val="FFFFFF"/>
+                </a:solidFill>
+              </a:rPr>
+              <a:t>चौथे स्तंभ से आह्वान — 10 मीडिया माँगें</a:t>
+            </a:r>
+          </a:p>
+        </p:txBody>
+      </p:sp>
+      <p:sp>
+        <p:nvSpPr>
+          <p:cNvPr id="7" name="TextBox 6"/>
+          <p:cNvSpPr txBox="1"/>
+          <p:nvPr/>
+        </p:nvSpPr>
+        <p:spPr>
+          <a:xfrm>
+            <a:off x="1417320" y="658368"/>
+            <a:ext cx="10424160" cy="411480"/>
+          </a:xfrm>
+          <a:prstGeom prst="rect">
+            <a:avLst/>
+          </a:prstGeom>
+          <a:noFill/>
+        </p:spPr>
+        <p:txBody>
+          <a:bodyPr wrap="square">
+            <a:spAutoFit/>
+          </a:bodyPr>
+          <a:lstStyle/>
+          <a:p>
+            <a:pPr algn="l"/>
+            <a:r>
+              <a:rPr sz="1200" b="1" i="0">
+                <a:solidFill>
+                  <a:srgbClr val="A0C8DC"/>
+                </a:solidFill>
+              </a:rPr>
+              <a:t>Call to the Fourth Estate — 10 Media Demands</a:t>
+            </a:r>
+          </a:p>
+        </p:txBody>
+      </p:sp>
+      <p:sp>
+        <p:nvSpPr>
+          <p:cNvPr id="8" name="Rectangle 7"/>
+          <p:cNvSpPr/>
+          <p:nvPr/>
+        </p:nvSpPr>
+        <p:spPr>
+          <a:xfrm>
+            <a:off x="274320" y="1170432"/>
+            <a:ext cx="11640312" cy="27432"/>
+          </a:xfrm>
+          <a:prstGeom prst="rect">
+            <a:avLst/>
+          </a:prstGeom>
+          <a:solidFill>
+            <a:srgbClr val="0D9488"/>
+          </a:solidFill>
+          <a:ln>
+            <a:noFill/>
+          </a:ln>
+        </p:spPr>
+        <p:style>
+          <a:lnRef idx="1">
+            <a:schemeClr val="accent1"/>
+          </a:lnRef>
+          <a:fillRef idx="3">
+            <a:schemeClr val="accent1"/>
+          </a:fillRef>
+          <a:effectRef idx="2">
+            <a:schemeClr val="accent1"/>
+          </a:effectRef>
+          <a:fontRef idx="minor">
+            <a:schemeClr val="lt1"/>
+          </a:fontRef>
+        </p:style>
+        <p:txBody>
+          <a:bodyPr rtlCol="0" anchor="ctr"/>
+          <a:lstStyle/>
+          <a:p>
+            <a:pPr algn="ctr"/>
+          </a:p>
+        </p:txBody>
+      </p:sp>
+      <p:sp>
+        <p:nvSpPr>
+          <p:cNvPr id="9" name="TextBox 8"/>
+          <p:cNvSpPr txBox="1"/>
+          <p:nvPr/>
+        </p:nvSpPr>
+        <p:spPr>
+          <a:xfrm>
+            <a:off x="274320" y="1280160"/>
+            <a:ext cx="5669280" cy="5029200"/>
+          </a:xfrm>
+          <a:prstGeom prst="rect">
+            <a:avLst/>
+          </a:prstGeom>
+          <a:noFill/>
+        </p:spPr>
+        <p:txBody>
+          <a:bodyPr wrap="square">
+            <a:spAutoFit/>
+          </a:bodyPr>
+          <a:lstStyle/>
+          <a:p>
+            <a:pPr algn="l"/>
+            <a:r>
+              <a:rPr sz="1100" b="0" i="0">
+                <a:solidFill>
+                  <a:srgbClr val="DCE1E6"/>
+                </a:solidFill>
+              </a:rPr>
+              <a:t>1.Delegation RTI 2.AS/FS Backdating CAG Audit 3.IP Login Audit→ACB 4.XEN Login
+Sting 5.DSC Location Check 6.Live Helpline Test 7.Morphed Photo Expose 8.Public
+Audit माँग 9.One Operator Three Roles Expose 10.Public Monitoring अनिवार्य।</a:t>
+            </a:r>
+          </a:p>
+        </p:txBody>
+      </p:sp>
+      <p:sp>
+        <p:nvSpPr>
+          <p:cNvPr id="10" name="TextBox 9"/>
+          <p:cNvSpPr txBox="1"/>
+          <p:nvPr/>
+        </p:nvSpPr>
+        <p:spPr>
+          <a:xfrm>
+            <a:off x="6217920" y="1280160"/>
+            <a:ext cx="5669280" cy="5029200"/>
+          </a:xfrm>
+          <a:prstGeom prst="rect">
+            <a:avLst/>
+          </a:prstGeom>
+          <a:noFill/>
+        </p:spPr>
+        <p:txBody>
+          <a:bodyPr wrap="square">
+            <a:spAutoFit/>
+          </a:bodyPr>
+          <a:lstStyle/>
+          <a:p>
+            <a:pPr algn="l"/>
+            <a:r>
+              <a:rPr sz="1050" b="0" i="1">
+                <a:solidFill>
+                  <a:srgbClr val="AAB9C3"/>
+                </a:solidFill>
+              </a:rPr>
+              <a:t>1.RTI on delegation circular 2.AS/FS backdating CAG audit 3.IP Login Audit→ACB
+4.XEN Login sting 5.DSC location check 6.Live helpline call test 7.Morphed photo
+expose 8.Public audit demand 9.One operator three roles expose 10.Public
+monitoring mandate.</a:t>
+            </a:r>
+          </a:p>
+        </p:txBody>
+      </p:sp>
+      <p:sp>
+        <p:nvSpPr>
+          <p:cNvPr id="11" name="Rectangle 10"/>
+          <p:cNvSpPr/>
+          <p:nvPr/>
+        </p:nvSpPr>
+        <p:spPr>
+          <a:xfrm>
+            <a:off x="6035040" y="1280160"/>
+            <a:ext cx="27432" cy="5029200"/>
+          </a:xfrm>
+          <a:prstGeom prst="rect">
+            <a:avLst/>
+          </a:prstGeom>
+          <a:solidFill>
+            <a:srgbClr val="0D9488"/>
+          </a:solidFill>
+          <a:ln>
+            <a:noFill/>
+          </a:ln>
+        </p:spPr>
+        <p:style>
+          <a:lnRef idx="1">
+            <a:schemeClr val="accent1"/>
+          </a:lnRef>
+          <a:fillRef idx="3">
+            <a:schemeClr val="accent1"/>
+          </a:fillRef>
+          <a:effectRef idx="2">
+            <a:schemeClr val="accent1"/>
+          </a:effectRef>
+          <a:fontRef idx="minor">
+            <a:schemeClr val="lt1"/>
+          </a:fontRef>
+        </p:style>
+        <p:txBody>
+          <a:bodyPr rtlCol="0" anchor="ctr"/>
+          <a:lstStyle/>
+          <a:p>
+            <a:pPr algn="ctr"/>
+          </a:p>
+        </p:txBody>
+      </p:sp>
+      <p:sp>
+        <p:nvSpPr>
+          <p:cNvPr id="12" name="TextBox 11"/>
+          <p:cNvSpPr txBox="1"/>
+          <p:nvPr/>
+        </p:nvSpPr>
+        <p:spPr>
+          <a:xfrm>
+            <a:off x="10972800" y="6492240"/>
+            <a:ext cx="1097280" cy="274320"/>
+          </a:xfrm>
+          <a:prstGeom prst="rect">
+            <a:avLst/>
+          </a:prstGeom>
+          <a:noFill/>
+        </p:spPr>
+        <p:txBody>
+          <a:bodyPr wrap="square">
+            <a:spAutoFit/>
+          </a:bodyPr>
+          <a:lstStyle/>
+          <a:p>
+            <a:pPr algn="r"/>
+            <a:r>
+              <a:rPr sz="800" b="0" i="0">
+                <a:solidFill>
+                  <a:srgbClr val="64788C"/>
+                </a:solidFill>
+              </a:rPr>
+              <a:t>16 / 16</a:t>
+            </a:r>
+          </a:p>
+        </p:txBody>
+      </p:sp>
+    </p:spTree>
+  </p:cSld>
+  <p:clrMapOvr>
+    <a:masterClrMapping/>
+  </p:clrMapOvr>
+</p:sld>
+</file>
+
+<file path=ppt/slides/slide17.xml><?xml version="1.0" encoding="utf-8"?>
 <p:sld xmlns:a="http://schemas.openxmlformats.org/drawingml/2006/main" xmlns:p="http://schemas.openxmlformats.org/presentationml/2006/main" xmlns:r="http://schemas.openxmlformats.org/officeDocument/2006/relationships">
   <p:cSld>
     <p:bg>
@@ -8040,7 +8500,7 @@
                   <a:srgbClr val="64788C"/>
                 </a:solidFill>
               </a:rPr>
-              <a:t>3 / 15</a:t>
+              <a:t>3 / 16</a:t>
             </a:r>
           </a:p>
         </p:txBody>
@@ -8489,7 +8949,7 @@
                   <a:srgbClr val="64788C"/>
                 </a:solidFill>
               </a:rPr>
-              <a:t>4 / 15</a:t>
+              <a:t>4 / 16</a:t>
             </a:r>
           </a:p>
         </p:txBody>
@@ -8939,7 +9399,7 @@
                   <a:srgbClr val="64788C"/>
                 </a:solidFill>
               </a:rPr>
-              <a:t>5 / 15</a:t>
+              <a:t>5 / 16</a:t>
             </a:r>
           </a:p>
         </p:txBody>
@@ -9389,7 +9849,7 @@
                   <a:srgbClr val="64788C"/>
                 </a:solidFill>
               </a:rPr>
-              <a:t>6 / 15</a:t>
+              <a:t>6 / 16</a:t>
             </a:r>
           </a:p>
         </p:txBody>
@@ -9841,7 +10301,7 @@
                   <a:srgbClr val="64788C"/>
                 </a:solidFill>
               </a:rPr>
-              <a:t>7 / 15</a:t>
+              <a:t>7 / 16</a:t>
             </a:r>
           </a:p>
         </p:txBody>
@@ -10290,7 +10750,7 @@
                   <a:srgbClr val="64788C"/>
                 </a:solidFill>
               </a:rPr>
-              <a:t>8 / 15</a:t>
+              <a:t>8 / 16</a:t>
             </a:r>
           </a:p>
         </p:txBody>
@@ -10740,7 +11200,7 @@
                   <a:srgbClr val="64788C"/>
                 </a:solidFill>
               </a:rPr>
-              <a:t>9 / 15</a:t>
+              <a:t>9 / 16</a:t>
             </a:r>
           </a:p>
         </p:txBody>

</xml_diff>

<commit_message>
Add recovery portal & legal pursuit chapter — impunity architecture exposed
New Chapter 8C (IFMS) + 6D (eMB):
- Q1: Why no Digitised Recovery Portal in 15 years?
  Portal would make every non-recovery visible + attributable
  to a named officer — exactly what the system avoids
- Q2: Why no legal pursuit or monitoring?
  Two explanations: Gross Negligence OR Complicity
  (same officer who paid refuses to collect = ACB referral)
- Limitation Period ticking clock — cases may already be
  time-barred forever, officer accountability required
- 5-point Recovery Accountability Framework:
  A. Recovery Portal on IFMS — 90 day deadline
  B. Mandatory legal notice within 30 days of rescission
  C. Litigation Register — department legal cell, monthly
  D. Limitation Period automatic alerts
  E. Same-officer overlap = automatic ACB referral
- All 6 DOCX/PDF/PPTX exports regenerated
- News.txt updated with full investigation text
</commit_message>
<xml_diff>
--- a/artifacts/rajasthan-ifms-crisis/IFMS-Rajasthan-Investigation.pptx
+++ b/artifacts/rajasthan-ifms-crisis/IFMS-Rajasthan-Investigation.pptx
@@ -22,6 +22,7 @@
     <p:sldId id="270" r:id="rId21"/>
     <p:sldId id="271" r:id="rId22"/>
     <p:sldId id="272" r:id="rId23"/>
+    <p:sldId id="273" r:id="rId24"/>
   </p:sldIdLst>
   <p:sldSz cx="12188952" cy="6858000" type="screen4x3"/>
   <p:notesSz cx="6858000" cy="9144000"/>
@@ -3969,7 +3970,7 @@
                   <a:srgbClr val="64788C"/>
                 </a:solidFill>
               </a:rPr>
-              <a:t>10 / 16</a:t>
+              <a:t>10 / 17</a:t>
             </a:r>
           </a:p>
         </p:txBody>
@@ -4419,7 +4420,7 @@
                   <a:srgbClr val="64788C"/>
                 </a:solidFill>
               </a:rPr>
-              <a:t>11 / 16</a:t>
+              <a:t>11 / 17</a:t>
             </a:r>
           </a:p>
         </p:txBody>
@@ -4869,7 +4870,7 @@
                   <a:srgbClr val="64788C"/>
                 </a:solidFill>
               </a:rPr>
-              <a:t>12 / 16</a:t>
+              <a:t>12 / 17</a:t>
             </a:r>
           </a:p>
         </p:txBody>
@@ -5319,7 +5320,7 @@
                   <a:srgbClr val="64788C"/>
                 </a:solidFill>
               </a:rPr>
-              <a:t>13 / 16</a:t>
+              <a:t>13 / 17</a:t>
             </a:r>
           </a:p>
         </p:txBody>
@@ -5653,12 +5654,9 @@
                   <a:srgbClr val="DCE1E6"/>
                 </a:solidFill>
               </a:rPr>
-              <a:t>~200 contracts rescinded — Risk and Cost tenders floated — लेकिन recovery
-monitor नहीं होती। तीन नामित मामले: (1) भैरवजी Bridge, बाँसवाड़ा — rescinded,
-वसूली शून्य। (2) Kotada Road, उदयपुर — rescinded, differential cost unrecovered।
-(3) Gannon Dunkerlay — established company, contract rescinded, department
-entitlement unexercised, company walked free। Rescission एक कागज़ी खतरा बन गया —
-असली financial liability नहीं। ठेकेदार के लिए contract तोड़ने का कोई दाम नहीं।</a:t>
+              <a:t>~200 रद्द अनुबंध — Risk and Cost tenders — recovery monitoring शून्य। भैरवजी
+Bridge बाँसवाड़ा, Kotada Road उदयपुर, Gannon Dunkerlay — तीनों में वसूली शून्य।
+Rescission केवल कागज़ी खतरा। Blacklist enforce नहीं।</a:t>
             </a:r>
           </a:p>
         </p:txBody>
@@ -5692,16 +5690,11 @@
                   <a:srgbClr val="AAB9C3"/>
                 </a:solidFill>
               </a:rPr>
-              <a:t>Approximately 200 contracts have been rescinded for incomplete execution in
-Rajasthan PWD. Risk-and-cost tenders were invited. But there is no regular
-monitoring of recovery against defaulters. Three named examples: (1) Bhairavji
-Bridge, Banswara — rescinded, risk-and-cost tender floated, zero recovery from
-contractor. (2) Kotada Road, Udaipur — rescinded, differential cost unrecovered.
-(3) Gannon Dunkerlay &amp; Company — established firm, contract rescinded,
-substantial department entitlement unexercised, company walked free. Pattern:
-rescission is a paper threat, not a real financial liability. Mandatory reforms:
-centralised risk-and-cost recovery register in IFMS, mandatory blacklisting
-until full recovery, named-case CAG audit and ACB investigation.</a:t>
+              <a:t>Three named cases: Bhairavji Bridge Banswara (rescinded, nil recovery), Kotada
+Road Udaipur (rescinded, nil recovery), Gannon Dunkerlay &amp; Co (rescinded,
+substantial dues unexercised — company walked free). State-wide pattern: ~200
+rescissions, zero systematic recovery monitoring. Rescission is a paper threat.
+No blacklist enforced. Taxpayer pays twice.</a:t>
             </a:r>
           </a:p>
         </p:txBody>
@@ -5778,7 +5771,7 @@
                   <a:srgbClr val="64788C"/>
                 </a:solidFill>
               </a:rPr>
-              <a:t>14 / 16</a:t>
+              <a:t>14 / 17</a:t>
             </a:r>
           </a:p>
         </p:txBody>
@@ -5967,7 +5960,7 @@
                   <a:srgbClr val="FFFFFF"/>
                 </a:solidFill>
               </a:rPr>
-              <a:t>Ch.9</a:t>
+              <a:t>Ch.8C</a:t>
             </a:r>
           </a:p>
         </p:txBody>
@@ -6001,7 +5994,7 @@
                   <a:srgbClr val="FFFFFF"/>
                 </a:solidFill>
               </a:rPr>
-              <a:t>सात तत्काल माँगें</a:t>
+              <a:t>Recovery Portal क्यों नहीं? Legal Pursuit क्यों नहीं? — Impunity का Architecture</a:t>
             </a:r>
           </a:p>
         </p:txBody>
@@ -6035,7 +6028,7 @@
                   <a:srgbClr val="A0C8DC"/>
                 </a:solidFill>
               </a:rPr>
-              <a:t>Seven Immediate Demands</a:t>
+              <a:t>Why No Digitised Recovery Portal? Why No Legal Pursuit? — Architecture of Impunity</a:t>
             </a:r>
           </a:p>
         </p:txBody>
@@ -6112,10 +6105,14 @@
                   <a:srgbClr val="DCE1E6"/>
                 </a:solidFill>
               </a:rPr>
-              <a:t>1. Statutory Delegation Order (Gazette Notification)। 2. नागरिक पारदर्शिता। 3.
-DSC अधिकारी के पास — operator के नहीं। 4. अनिवार्य Training। 5. Portal bugs
-deadline के साथ fix हों। 6. 24×7 Dedicated Helpline। 7. Independent Monitoring
-Committee।</a:t>
+              <a:t>दो अनुत्तरित प्रश्न पूरे तंत्र को उघाड़ते हैं। प्रश्न 1: Digitised Recovery
+Portal क्यों नहीं? 15 वर्षों में नहीं बना — क्योंकि यह portal हर non-recovery को
+visible और attributable बना देता। प्रश्न 2: Legal pursuit और monitoring क्यों
+नहीं? Recovery करना department का legal obligation है। दो उत्तर: A) Gross
+Negligence — governance पतन। B) Complicity — जिस हाथ ने payments किए वही
+recovery रोक रहा है। पाँच-बिंदु framework: 90 दिन में Recovery Portal; 30 दिन
+में legal notice; Litigation Register; Limitation Period alerts; Same-officer
+overlap = automatic ACB referral।</a:t>
             </a:r>
           </a:p>
         </p:txBody>
@@ -6149,10 +6146,19 @@
                   <a:srgbClr val="AAB9C3"/>
                 </a:solidFill>
               </a:rPr>
-              <a:t>1. Statutory Delegation Order (Gazette Notification). 2. Citizen Transparency.
-3. DSC must stay with officer — not at computer centre. 4. Mandatory
-comprehensive training. 5. Portal bugs fixed with deadline. 6. 24x7 dedicated
-helpline. 7. Independent Monitoring Committee.</a:t>
+              <a:t>Two unanswered questions expose the system. Q1: Why no Digitised Recovery
+Portal? Government has e-Procurement, IFMS, PayManager, NIC capacity. A portal
+could be built in 90 days on IFMS infrastructure — showing every rescinded
+contract, recoverable amount, officer responsible, legal notice status,
+limitation period alerts, and public access. It does not exist because it would
+make every non-recovery visible and attributable to a named officer. Q2: Why no
+legal pursuit or monitoring? Recovery is a legal obligation — not optional. Two
+explanations: A) Gross Negligence — management systems absent. B) Complicity —
+the same officer who processed and paid the contract refuses to initiate
+recovery. That overlap should be automatic ACB referral. Five-point framework:
+Recovery Portal in 90 days; mandatory legal notice in 30 days of rescission;
+litigation register monthly updated; limitation period automatic alerts; same-
+officer overlap triggers ACB referral.</a:t>
             </a:r>
           </a:p>
         </p:txBody>
@@ -6229,7 +6235,7 @@
                   <a:srgbClr val="64788C"/>
                 </a:solidFill>
               </a:rPr>
-              <a:t>15 / 16</a:t>
+              <a:t>15 / 17</a:t>
             </a:r>
           </a:p>
         </p:txBody>
@@ -6418,7 +6424,7 @@
                   <a:srgbClr val="FFFFFF"/>
                 </a:solidFill>
               </a:rPr>
-              <a:t>Ch.10</a:t>
+              <a:t>Ch.9</a:t>
             </a:r>
           </a:p>
         </p:txBody>
@@ -6452,7 +6458,7 @@
                   <a:srgbClr val="FFFFFF"/>
                 </a:solidFill>
               </a:rPr>
-              <a:t>चौथे स्तंभ से आह्वान — 10 मीडिया माँगें</a:t>
+              <a:t>सात तत्काल माँगें</a:t>
             </a:r>
           </a:p>
         </p:txBody>
@@ -6486,7 +6492,7 @@
                   <a:srgbClr val="A0C8DC"/>
                 </a:solidFill>
               </a:rPr>
-              <a:t>Call to the Fourth Estate — 10 Media Demands</a:t>
+              <a:t>Seven Immediate Demands</a:t>
             </a:r>
           </a:p>
         </p:txBody>
@@ -6563,9 +6569,10 @@
                   <a:srgbClr val="DCE1E6"/>
                 </a:solidFill>
               </a:rPr>
-              <a:t>1.Delegation RTI 2.AS/FS Backdating CAG Audit 3.IP Login Audit→ACB 4.XEN Login
-Sting 5.DSC Location Check 6.Live Helpline Test 7.Morphed Photo Expose 8.Public
-Audit माँग 9.One Operator Three Roles Expose 10.Public Monitoring अनिवार्य।</a:t>
+              <a:t>1. Statutory Delegation Order (Gazette Notification)। 2. नागरिक पारदर्शिता। 3.
+DSC अधिकारी के पास — operator के नहीं। 4. अनिवार्य Training। 5. Portal bugs
+deadline के साथ fix हों। 6. 24×7 Dedicated Helpline। 7. Independent Monitoring
+Committee।</a:t>
             </a:r>
           </a:p>
         </p:txBody>
@@ -6599,10 +6606,10 @@
                   <a:srgbClr val="AAB9C3"/>
                 </a:solidFill>
               </a:rPr>
-              <a:t>1.RTI on delegation circular 2.AS/FS backdating CAG audit 3.IP Login Audit→ACB
-4.XEN Login sting 5.DSC location check 6.Live helpline call test 7.Morphed photo
-expose 8.Public audit demand 9.One operator three roles expose 10.Public
-monitoring mandate.</a:t>
+              <a:t>1. Statutory Delegation Order (Gazette Notification). 2. Citizen Transparency.
+3. DSC must stay with officer — not at computer centre. 4. Mandatory
+comprehensive training. 5. Portal bugs fixed with deadline. 6. 24x7 dedicated
+helpline. 7. Independent Monitoring Committee.</a:t>
             </a:r>
           </a:p>
         </p:txBody>
@@ -6679,7 +6686,7 @@
                   <a:srgbClr val="64788C"/>
                 </a:solidFill>
               </a:rPr>
-              <a:t>16 / 16</a:t>
+              <a:t>16 / 17</a:t>
             </a:r>
           </a:p>
         </p:txBody>
@@ -6693,6 +6700,456 @@
 </file>
 
 <file path=ppt/slides/slide17.xml><?xml version="1.0" encoding="utf-8"?>
+<p:sld xmlns:a="http://schemas.openxmlformats.org/drawingml/2006/main" xmlns:p="http://schemas.openxmlformats.org/presentationml/2006/main" xmlns:r="http://schemas.openxmlformats.org/officeDocument/2006/relationships">
+  <p:cSld>
+    <p:bg>
+      <p:bgPr>
+        <a:solidFill>
+          <a:srgbClr val="1C1814"/>
+        </a:solidFill>
+        <a:effectLst/>
+      </p:bgPr>
+    </p:bg>
+    <p:spTree>
+      <p:nvGrpSpPr>
+        <p:cNvPr id="1" name=""/>
+        <p:cNvGrpSpPr/>
+        <p:nvPr/>
+      </p:nvGrpSpPr>
+      <p:grpSpPr/>
+      <p:sp>
+        <p:nvSpPr>
+          <p:cNvPr id="2" name="Rectangle 1"/>
+          <p:cNvSpPr/>
+          <p:nvPr/>
+        </p:nvSpPr>
+        <p:spPr>
+          <a:xfrm>
+            <a:off x="0" y="0"/>
+            <a:ext cx="12188952" cy="64008"/>
+          </a:xfrm>
+          <a:prstGeom prst="rect">
+            <a:avLst/>
+          </a:prstGeom>
+          <a:solidFill>
+            <a:srgbClr val="0D9488"/>
+          </a:solidFill>
+          <a:ln>
+            <a:noFill/>
+          </a:ln>
+        </p:spPr>
+        <p:style>
+          <a:lnRef idx="1">
+            <a:schemeClr val="accent1"/>
+          </a:lnRef>
+          <a:fillRef idx="3">
+            <a:schemeClr val="accent1"/>
+          </a:fillRef>
+          <a:effectRef idx="2">
+            <a:schemeClr val="accent1"/>
+          </a:effectRef>
+          <a:fontRef idx="minor">
+            <a:schemeClr val="lt1"/>
+          </a:fontRef>
+        </p:style>
+        <p:txBody>
+          <a:bodyPr rtlCol="0" anchor="ctr"/>
+          <a:lstStyle/>
+          <a:p>
+            <a:pPr algn="ctr"/>
+          </a:p>
+        </p:txBody>
+      </p:sp>
+      <p:sp>
+        <p:nvSpPr>
+          <p:cNvPr id="3" name="Rectangle 2"/>
+          <p:cNvSpPr/>
+          <p:nvPr/>
+        </p:nvSpPr>
+        <p:spPr>
+          <a:xfrm>
+            <a:off x="0" y="6793992"/>
+            <a:ext cx="12188952" cy="64008"/>
+          </a:xfrm>
+          <a:prstGeom prst="rect">
+            <a:avLst/>
+          </a:prstGeom>
+          <a:solidFill>
+            <a:srgbClr val="0D9488"/>
+          </a:solidFill>
+          <a:ln>
+            <a:noFill/>
+          </a:ln>
+        </p:spPr>
+        <p:style>
+          <a:lnRef idx="1">
+            <a:schemeClr val="accent1"/>
+          </a:lnRef>
+          <a:fillRef idx="3">
+            <a:schemeClr val="accent1"/>
+          </a:fillRef>
+          <a:effectRef idx="2">
+            <a:schemeClr val="accent1"/>
+          </a:effectRef>
+          <a:fontRef idx="minor">
+            <a:schemeClr val="lt1"/>
+          </a:fontRef>
+        </p:style>
+        <p:txBody>
+          <a:bodyPr rtlCol="0" anchor="ctr"/>
+          <a:lstStyle/>
+          <a:p>
+            <a:pPr algn="ctr"/>
+          </a:p>
+        </p:txBody>
+      </p:sp>
+      <p:sp>
+        <p:nvSpPr>
+          <p:cNvPr id="4" name="Rectangle 3"/>
+          <p:cNvSpPr/>
+          <p:nvPr/>
+        </p:nvSpPr>
+        <p:spPr>
+          <a:xfrm>
+            <a:off x="274320" y="164592"/>
+            <a:ext cx="1005840" cy="411480"/>
+          </a:xfrm>
+          <a:prstGeom prst="rect">
+            <a:avLst/>
+          </a:prstGeom>
+          <a:solidFill>
+            <a:srgbClr val="0D9488"/>
+          </a:solidFill>
+          <a:ln>
+            <a:noFill/>
+          </a:ln>
+        </p:spPr>
+        <p:style>
+          <a:lnRef idx="1">
+            <a:schemeClr val="accent1"/>
+          </a:lnRef>
+          <a:fillRef idx="3">
+            <a:schemeClr val="accent1"/>
+          </a:fillRef>
+          <a:effectRef idx="2">
+            <a:schemeClr val="accent1"/>
+          </a:effectRef>
+          <a:fontRef idx="minor">
+            <a:schemeClr val="lt1"/>
+          </a:fontRef>
+        </p:style>
+        <p:txBody>
+          <a:bodyPr rtlCol="0" anchor="ctr"/>
+          <a:lstStyle/>
+          <a:p>
+            <a:pPr algn="ctr"/>
+          </a:p>
+        </p:txBody>
+      </p:sp>
+      <p:sp>
+        <p:nvSpPr>
+          <p:cNvPr id="5" name="TextBox 4"/>
+          <p:cNvSpPr txBox="1"/>
+          <p:nvPr/>
+        </p:nvSpPr>
+        <p:spPr>
+          <a:xfrm>
+            <a:off x="274320" y="164592"/>
+            <a:ext cx="1005840" cy="411480"/>
+          </a:xfrm>
+          <a:prstGeom prst="rect">
+            <a:avLst/>
+          </a:prstGeom>
+          <a:noFill/>
+        </p:spPr>
+        <p:txBody>
+          <a:bodyPr wrap="square">
+            <a:spAutoFit/>
+          </a:bodyPr>
+          <a:lstStyle/>
+          <a:p>
+            <a:pPr algn="ctr"/>
+            <a:r>
+              <a:rPr sz="1100" b="1" i="0">
+                <a:solidFill>
+                  <a:srgbClr val="FFFFFF"/>
+                </a:solidFill>
+              </a:rPr>
+              <a:t>Ch.10</a:t>
+            </a:r>
+          </a:p>
+        </p:txBody>
+      </p:sp>
+      <p:sp>
+        <p:nvSpPr>
+          <p:cNvPr id="6" name="TextBox 5"/>
+          <p:cNvSpPr txBox="1"/>
+          <p:nvPr/>
+        </p:nvSpPr>
+        <p:spPr>
+          <a:xfrm>
+            <a:off x="1417320" y="137160"/>
+            <a:ext cx="10424160" cy="548640"/>
+          </a:xfrm>
+          <a:prstGeom prst="rect">
+            <a:avLst/>
+          </a:prstGeom>
+          <a:noFill/>
+        </p:spPr>
+        <p:txBody>
+          <a:bodyPr wrap="square">
+            <a:spAutoFit/>
+          </a:bodyPr>
+          <a:lstStyle/>
+          <a:p>
+            <a:pPr algn="l"/>
+            <a:r>
+              <a:rPr sz="1800" b="1" i="0">
+                <a:solidFill>
+                  <a:srgbClr val="FFFFFF"/>
+                </a:solidFill>
+              </a:rPr>
+              <a:t>चौथे स्तंभ से आह्वान — 10 मीडिया माँगें</a:t>
+            </a:r>
+          </a:p>
+        </p:txBody>
+      </p:sp>
+      <p:sp>
+        <p:nvSpPr>
+          <p:cNvPr id="7" name="TextBox 6"/>
+          <p:cNvSpPr txBox="1"/>
+          <p:nvPr/>
+        </p:nvSpPr>
+        <p:spPr>
+          <a:xfrm>
+            <a:off x="1417320" y="658368"/>
+            <a:ext cx="10424160" cy="411480"/>
+          </a:xfrm>
+          <a:prstGeom prst="rect">
+            <a:avLst/>
+          </a:prstGeom>
+          <a:noFill/>
+        </p:spPr>
+        <p:txBody>
+          <a:bodyPr wrap="square">
+            <a:spAutoFit/>
+          </a:bodyPr>
+          <a:lstStyle/>
+          <a:p>
+            <a:pPr algn="l"/>
+            <a:r>
+              <a:rPr sz="1200" b="1" i="0">
+                <a:solidFill>
+                  <a:srgbClr val="A0C8DC"/>
+                </a:solidFill>
+              </a:rPr>
+              <a:t>Call to the Fourth Estate — 10 Media Demands</a:t>
+            </a:r>
+          </a:p>
+        </p:txBody>
+      </p:sp>
+      <p:sp>
+        <p:nvSpPr>
+          <p:cNvPr id="8" name="Rectangle 7"/>
+          <p:cNvSpPr/>
+          <p:nvPr/>
+        </p:nvSpPr>
+        <p:spPr>
+          <a:xfrm>
+            <a:off x="274320" y="1170432"/>
+            <a:ext cx="11640312" cy="27432"/>
+          </a:xfrm>
+          <a:prstGeom prst="rect">
+            <a:avLst/>
+          </a:prstGeom>
+          <a:solidFill>
+            <a:srgbClr val="0D9488"/>
+          </a:solidFill>
+          <a:ln>
+            <a:noFill/>
+          </a:ln>
+        </p:spPr>
+        <p:style>
+          <a:lnRef idx="1">
+            <a:schemeClr val="accent1"/>
+          </a:lnRef>
+          <a:fillRef idx="3">
+            <a:schemeClr val="accent1"/>
+          </a:fillRef>
+          <a:effectRef idx="2">
+            <a:schemeClr val="accent1"/>
+          </a:effectRef>
+          <a:fontRef idx="minor">
+            <a:schemeClr val="lt1"/>
+          </a:fontRef>
+        </p:style>
+        <p:txBody>
+          <a:bodyPr rtlCol="0" anchor="ctr"/>
+          <a:lstStyle/>
+          <a:p>
+            <a:pPr algn="ctr"/>
+          </a:p>
+        </p:txBody>
+      </p:sp>
+      <p:sp>
+        <p:nvSpPr>
+          <p:cNvPr id="9" name="TextBox 8"/>
+          <p:cNvSpPr txBox="1"/>
+          <p:nvPr/>
+        </p:nvSpPr>
+        <p:spPr>
+          <a:xfrm>
+            <a:off x="274320" y="1280160"/>
+            <a:ext cx="5669280" cy="5029200"/>
+          </a:xfrm>
+          <a:prstGeom prst="rect">
+            <a:avLst/>
+          </a:prstGeom>
+          <a:noFill/>
+        </p:spPr>
+        <p:txBody>
+          <a:bodyPr wrap="square">
+            <a:spAutoFit/>
+          </a:bodyPr>
+          <a:lstStyle/>
+          <a:p>
+            <a:pPr algn="l"/>
+            <a:r>
+              <a:rPr sz="1100" b="0" i="0">
+                <a:solidFill>
+                  <a:srgbClr val="DCE1E6"/>
+                </a:solidFill>
+              </a:rPr>
+              <a:t>1.Delegation RTI 2.AS/FS Backdating CAG Audit 3.IP Login Audit→ACB 4.XEN Login
+Sting 5.DSC Location Check 6.Live Helpline Test 7.Morphed Photo Expose 8.Public
+Audit माँग 9.One Operator Three Roles Expose 10.Public Monitoring अनिवार्य।</a:t>
+            </a:r>
+          </a:p>
+        </p:txBody>
+      </p:sp>
+      <p:sp>
+        <p:nvSpPr>
+          <p:cNvPr id="10" name="TextBox 9"/>
+          <p:cNvSpPr txBox="1"/>
+          <p:nvPr/>
+        </p:nvSpPr>
+        <p:spPr>
+          <a:xfrm>
+            <a:off x="6217920" y="1280160"/>
+            <a:ext cx="5669280" cy="5029200"/>
+          </a:xfrm>
+          <a:prstGeom prst="rect">
+            <a:avLst/>
+          </a:prstGeom>
+          <a:noFill/>
+        </p:spPr>
+        <p:txBody>
+          <a:bodyPr wrap="square">
+            <a:spAutoFit/>
+          </a:bodyPr>
+          <a:lstStyle/>
+          <a:p>
+            <a:pPr algn="l"/>
+            <a:r>
+              <a:rPr sz="1050" b="0" i="1">
+                <a:solidFill>
+                  <a:srgbClr val="AAB9C3"/>
+                </a:solidFill>
+              </a:rPr>
+              <a:t>1.RTI on delegation circular 2.AS/FS backdating CAG audit 3.IP Login Audit→ACB
+4.XEN Login sting 5.DSC location check 6.Live helpline call test 7.Morphed photo
+expose 8.Public audit demand 9.One operator three roles expose 10.Public
+monitoring mandate.</a:t>
+            </a:r>
+          </a:p>
+        </p:txBody>
+      </p:sp>
+      <p:sp>
+        <p:nvSpPr>
+          <p:cNvPr id="11" name="Rectangle 10"/>
+          <p:cNvSpPr/>
+          <p:nvPr/>
+        </p:nvSpPr>
+        <p:spPr>
+          <a:xfrm>
+            <a:off x="6035040" y="1280160"/>
+            <a:ext cx="27432" cy="5029200"/>
+          </a:xfrm>
+          <a:prstGeom prst="rect">
+            <a:avLst/>
+          </a:prstGeom>
+          <a:solidFill>
+            <a:srgbClr val="0D9488"/>
+          </a:solidFill>
+          <a:ln>
+            <a:noFill/>
+          </a:ln>
+        </p:spPr>
+        <p:style>
+          <a:lnRef idx="1">
+            <a:schemeClr val="accent1"/>
+          </a:lnRef>
+          <a:fillRef idx="3">
+            <a:schemeClr val="accent1"/>
+          </a:fillRef>
+          <a:effectRef idx="2">
+            <a:schemeClr val="accent1"/>
+          </a:effectRef>
+          <a:fontRef idx="minor">
+            <a:schemeClr val="lt1"/>
+          </a:fontRef>
+        </p:style>
+        <p:txBody>
+          <a:bodyPr rtlCol="0" anchor="ctr"/>
+          <a:lstStyle/>
+          <a:p>
+            <a:pPr algn="ctr"/>
+          </a:p>
+        </p:txBody>
+      </p:sp>
+      <p:sp>
+        <p:nvSpPr>
+          <p:cNvPr id="12" name="TextBox 11"/>
+          <p:cNvSpPr txBox="1"/>
+          <p:nvPr/>
+        </p:nvSpPr>
+        <p:spPr>
+          <a:xfrm>
+            <a:off x="10972800" y="6492240"/>
+            <a:ext cx="1097280" cy="274320"/>
+          </a:xfrm>
+          <a:prstGeom prst="rect">
+            <a:avLst/>
+          </a:prstGeom>
+          <a:noFill/>
+        </p:spPr>
+        <p:txBody>
+          <a:bodyPr wrap="square">
+            <a:spAutoFit/>
+          </a:bodyPr>
+          <a:lstStyle/>
+          <a:p>
+            <a:pPr algn="r"/>
+            <a:r>
+              <a:rPr sz="800" b="0" i="0">
+                <a:solidFill>
+                  <a:srgbClr val="64788C"/>
+                </a:solidFill>
+              </a:rPr>
+              <a:t>17 / 17</a:t>
+            </a:r>
+          </a:p>
+        </p:txBody>
+      </p:sp>
+    </p:spTree>
+  </p:cSld>
+  <p:clrMapOvr>
+    <a:masterClrMapping/>
+  </p:clrMapOvr>
+</p:sld>
+</file>
+
+<file path=ppt/slides/slide18.xml><?xml version="1.0" encoding="utf-8"?>
 <p:sld xmlns:a="http://schemas.openxmlformats.org/drawingml/2006/main" xmlns:p="http://schemas.openxmlformats.org/presentationml/2006/main" xmlns:r="http://schemas.openxmlformats.org/officeDocument/2006/relationships">
   <p:cSld>
     <p:bg>
@@ -8500,7 +8957,7 @@
                   <a:srgbClr val="64788C"/>
                 </a:solidFill>
               </a:rPr>
-              <a:t>3 / 16</a:t>
+              <a:t>3 / 17</a:t>
             </a:r>
           </a:p>
         </p:txBody>
@@ -8949,7 +9406,7 @@
                   <a:srgbClr val="64788C"/>
                 </a:solidFill>
               </a:rPr>
-              <a:t>4 / 16</a:t>
+              <a:t>4 / 17</a:t>
             </a:r>
           </a:p>
         </p:txBody>
@@ -9399,7 +9856,7 @@
                   <a:srgbClr val="64788C"/>
                 </a:solidFill>
               </a:rPr>
-              <a:t>5 / 16</a:t>
+              <a:t>5 / 17</a:t>
             </a:r>
           </a:p>
         </p:txBody>
@@ -9849,7 +10306,7 @@
                   <a:srgbClr val="64788C"/>
                 </a:solidFill>
               </a:rPr>
-              <a:t>6 / 16</a:t>
+              <a:t>6 / 17</a:t>
             </a:r>
           </a:p>
         </p:txBody>
@@ -10301,7 +10758,7 @@
                   <a:srgbClr val="64788C"/>
                 </a:solidFill>
               </a:rPr>
-              <a:t>7 / 16</a:t>
+              <a:t>7 / 17</a:t>
             </a:r>
           </a:p>
         </p:txBody>
@@ -10750,7 +11207,7 @@
                   <a:srgbClr val="64788C"/>
                 </a:solidFill>
               </a:rPr>
-              <a:t>8 / 16</a:t>
+              <a:t>8 / 17</a:t>
             </a:r>
           </a:p>
         </p:txBody>
@@ -11200,7 +11657,7 @@
                   <a:srgbClr val="64788C"/>
                 </a:solidFill>
               </a:rPr>
-              <a:t>9 / 16</a:t>
+              <a:t>9 / 17</a:t>
             </a:r>
           </a:p>
         </p:txBody>

</xml_diff>